<commit_message>
odata: capa director-facing en T&T (Turner & Townsend) + .pptx regenerado (9 slides, roadmap 4-6m)
</commit_message>
<xml_diff>
--- a/odata/ODATA_QR03_Single_Source_of_Truth.pptx
+++ b/odata/ODATA_QR03_Single_Source_of_Truth.pptx
@@ -3332,7 +3332,7 @@
                 </a:solidFill>
                 <a:latin typeface="Arial"/>
               </a:rPr>
-              <a:t>turner &amp; townsend    ·    ODATA QR03    ·    Confidential</a:t>
+              <a:t>Turner &amp; Townsend    ·    ODATA QR03    ·    Confidential</a:t>
             </a:r>
           </a:p>
         </p:txBody>
@@ -3868,7 +3868,7 @@
                 </a:solidFill>
                 <a:latin typeface="Arial"/>
               </a:rPr>
-              <a:t>turner &amp; townsend    ·    ODATA QR03    ·    Confidential</a:t>
+              <a:t>Turner &amp; Townsend    ·    ODATA QR03    ·    Confidential</a:t>
             </a:r>
           </a:p>
         </p:txBody>
@@ -4510,7 +4510,7 @@
                 </a:solidFill>
                 <a:latin typeface="Arial"/>
               </a:rPr>
-              <a:t>turner &amp; townsend    ·    ODATA QR03    ·    Confidential</a:t>
+              <a:t>Turner &amp; Townsend    ·    ODATA QR03    ·    Confidential</a:t>
             </a:r>
           </a:p>
         </p:txBody>
@@ -4912,7 +4912,7 @@
                 </a:solidFill>
                 <a:latin typeface="Arial"/>
               </a:rPr>
-              <a:t>turner &amp; townsend    ·    ODATA QR03    ·    Confidential</a:t>
+              <a:t>Turner &amp; Townsend    ·    ODATA QR03    ·    Confidential</a:t>
             </a:r>
           </a:p>
         </p:txBody>
@@ -5458,7 +5458,7 @@
                 </a:solidFill>
                 <a:latin typeface="Arial"/>
               </a:rPr>
-              <a:t>turner &amp; townsend    ·    ODATA QR03    ·    Confidential</a:t>
+              <a:t>Turner &amp; Townsend    ·    ODATA QR03    ·    Confidential</a:t>
             </a:r>
           </a:p>
         </p:txBody>
@@ -6189,7 +6189,7 @@
                 </a:solidFill>
                 <a:latin typeface="Arial"/>
               </a:rPr>
-              <a:t>turner &amp; townsend    ·    ODATA QR03    ·    Confidential</a:t>
+              <a:t>Turner &amp; Townsend    ·    ODATA QR03    ·    Confidential</a:t>
             </a:r>
           </a:p>
         </p:txBody>
@@ -6634,7 +6634,7 @@
                 </a:solidFill>
                 <a:latin typeface="Arial"/>
               </a:rPr>
-              <a:t>turner &amp; townsend    ·    ODATA QR03    ·    Confidential</a:t>
+              <a:t>Turner &amp; Townsend    ·    ODATA QR03    ·    Confidential</a:t>
             </a:r>
           </a:p>
         </p:txBody>
@@ -7176,7 +7176,7 @@
                 </a:solidFill>
                 <a:latin typeface="Arial"/>
               </a:rPr>
-              <a:t>turner &amp; townsend    ·    ODATA QR03    ·    Confidential</a:t>
+              <a:t>Turner &amp; Townsend    ·    ODATA QR03    ·    Confidential</a:t>
             </a:r>
           </a:p>
         </p:txBody>
@@ -7408,7 +7408,7 @@
                 </a:solidFill>
                 <a:latin typeface="Arial"/>
               </a:rPr>
-              <a:t>turner &amp; townsend</a:t>
+              <a:t>Turner &amp; Townsend</a:t>
             </a:r>
             <a:r>
               <a:rPr sz="1200">

</xml_diff>